<commit_message>
Mentor photos for Carla, Nick, Wes and Gerald; builders use them automatically
Co-Authored-By: Claude Sonnet 5.5 <noreply@anthropic.com>
Claude-Session: https://claude.ai/code/session_011Ayydt3bbwxJJGtBUdBGUR
</commit_message>
<xml_diff>
--- a/templates/carousels/posts/05-10-2026-mon-teachers-day-five-mentors.pptx
+++ b/templates/carousels/posts/05-10-2026-mon-teachers-day-five-mentors.pptx
@@ -3979,7 +3979,7 @@
       <p:grpSpPr/>
       <p:pic>
         <p:nvPicPr>
-          <p:cNvPr id="2" name="Picture 1" descr="1579110998431298875.jpg"/>
+          <p:cNvPr id="2" name="Picture 1" descr="1094065242132244762.jpg"/>
           <p:cNvPicPr>
             <a:picLocks noChangeAspect="1"/>
           </p:cNvPicPr>
@@ -4540,16 +4540,180 @@
           </a:p>
         </p:txBody>
       </p:sp>
-      <p:sp>
-        <p:nvSpPr>
-          <p:cNvPr id="3" name="Oval 2"/>
-          <p:cNvSpPr/>
-          <p:nvPr/>
-        </p:nvSpPr>
+      <p:pic>
+        <p:nvPicPr>
+          <p:cNvPr id="3" name="Picture 2" descr=".circle-440.png"/>
+          <p:cNvPicPr>
+            <a:picLocks noChangeAspect="1"/>
+          </p:cNvPicPr>
+          <p:nvPr/>
+        </p:nvPicPr>
+        <p:blipFill>
+          <a:blip r:embed="rId3"/>
+          <a:stretch>
+            <a:fillRect/>
+          </a:stretch>
+        </p:blipFill>
         <p:spPr>
           <a:xfrm>
             <a:off x="3048000" y="1047750"/>
             <a:ext cx="4191000" cy="4191000"/>
+          </a:xfrm>
+          <a:prstGeom prst="rect">
+            <a:avLst/>
+          </a:prstGeom>
+        </p:spPr>
+      </p:pic>
+      <p:sp>
+        <p:nvSpPr>
+          <p:cNvPr id="4" name="TextBox 3"/>
+          <p:cNvSpPr txBox="1"/>
+          <p:nvPr/>
+        </p:nvSpPr>
+        <p:spPr>
+          <a:xfrm>
+            <a:off x="762000" y="5905500"/>
+            <a:ext cx="8763000" cy="762000"/>
+          </a:xfrm>
+          <a:prstGeom prst="rect">
+            <a:avLst/>
+          </a:prstGeom>
+          <a:noFill/>
+        </p:spPr>
+        <p:txBody>
+          <a:bodyPr wrap="square" lIns="0" rIns="0" tIns="0" bIns="0" anchor="t">
+            <a:spAutoFit/>
+          </a:bodyPr>
+          <a:lstStyle/>
+          <a:p>
+            <a:pPr algn="ctr"/>
+            <a:r>
+              <a:rPr sz="4800" b="1" i="0">
+                <a:solidFill>
+                  <a:srgbClr val="22371F"/>
+                </a:solidFill>
+                <a:latin typeface="Montserrat"/>
+              </a:rPr>
+              <a:t>Dr. Carla Portugal</a:t>
+            </a:r>
+          </a:p>
+        </p:txBody>
+      </p:sp>
+      <p:sp>
+        <p:nvSpPr>
+          <p:cNvPr id="5" name="TextBox 4"/>
+          <p:cNvSpPr txBox="1"/>
+          <p:nvPr/>
+        </p:nvSpPr>
+        <p:spPr>
+          <a:xfrm>
+            <a:off x="762000" y="6715125"/>
+            <a:ext cx="8763000" cy="571500"/>
+          </a:xfrm>
+          <a:prstGeom prst="rect">
+            <a:avLst/>
+          </a:prstGeom>
+          <a:noFill/>
+        </p:spPr>
+        <p:txBody>
+          <a:bodyPr wrap="square" lIns="0" rIns="0" tIns="0" bIns="0" anchor="t">
+            <a:spAutoFit/>
+          </a:bodyPr>
+          <a:lstStyle/>
+          <a:p>
+            <a:pPr algn="ctr"/>
+            <a:r>
+              <a:rPr sz="3300" b="0" i="0">
+                <a:solidFill>
+                  <a:srgbClr val="156826"/>
+                </a:solidFill>
+                <a:latin typeface="Source Sans 3"/>
+              </a:rPr>
+              <a:t>Science Leader</a:t>
+            </a:r>
+          </a:p>
+        </p:txBody>
+      </p:sp>
+      <p:sp>
+        <p:nvSpPr>
+          <p:cNvPr id="6" name="TextBox 5"/>
+          <p:cNvSpPr txBox="1"/>
+          <p:nvPr/>
+        </p:nvSpPr>
+        <p:spPr>
+          <a:xfrm>
+            <a:off x="762000" y="7620000"/>
+            <a:ext cx="8763000" cy="3619500"/>
+          </a:xfrm>
+          <a:prstGeom prst="rect">
+            <a:avLst/>
+          </a:prstGeom>
+          <a:noFill/>
+        </p:spPr>
+        <p:txBody>
+          <a:bodyPr wrap="square" lIns="0" rIns="0" tIns="0" bIns="0" anchor="t">
+            <a:spAutoFit/>
+          </a:bodyPr>
+          <a:lstStyle/>
+          <a:p>
+            <a:pPr algn="ctr"/>
+            <a:r>
+              <a:rPr sz="5700" b="0" i="0">
+                <a:solidFill>
+                  <a:srgbClr val="22371F"/>
+                </a:solidFill>
+                <a:latin typeface="Source Sans 3"/>
+              </a:rPr>
+              <a:t>[COPY: Allison] “[PLACEHOLDER tip]”</a:t>
+            </a:r>
+          </a:p>
+        </p:txBody>
+      </p:sp>
+      <p:sp>
+        <p:nvSpPr>
+          <p:cNvPr id="7" name="TextBox 6"/>
+          <p:cNvSpPr txBox="1"/>
+          <p:nvPr/>
+        </p:nvSpPr>
+        <p:spPr>
+          <a:xfrm>
+            <a:off x="571500" y="12192000"/>
+            <a:ext cx="9144000" cy="342900"/>
+          </a:xfrm>
+          <a:prstGeom prst="rect">
+            <a:avLst/>
+          </a:prstGeom>
+          <a:noFill/>
+        </p:spPr>
+        <p:txBody>
+          <a:bodyPr wrap="square" lIns="0" rIns="0" tIns="0" bIns="0" anchor="t">
+            <a:spAutoFit/>
+          </a:bodyPr>
+          <a:lstStyle/>
+          <a:p>
+            <a:pPr algn="l"/>
+            <a:r>
+              <a:rPr sz="3000" b="1" i="0">
+                <a:solidFill>
+                  <a:srgbClr val="6A665C"/>
+                </a:solidFill>
+                <a:latin typeface="Montserrat"/>
+              </a:rPr>
+              <a:t>@soilfoodwebschool</a:t>
+            </a:r>
+          </a:p>
+        </p:txBody>
+      </p:sp>
+      <p:sp>
+        <p:nvSpPr>
+          <p:cNvPr id="8" name="Oval 7"/>
+          <p:cNvSpPr/>
+          <p:nvPr/>
+        </p:nvSpPr>
+        <p:spPr>
+          <a:xfrm>
+            <a:off x="7715250" y="12363450"/>
+            <a:ext cx="152400" cy="152400"/>
           </a:xfrm>
           <a:prstGeom prst="ellipse">
             <a:avLst/>
@@ -4586,188 +4750,57 @@
       </p:sp>
       <p:sp>
         <p:nvSpPr>
-          <p:cNvPr id="4" name="TextBox 3"/>
-          <p:cNvSpPr txBox="1"/>
-          <p:nvPr/>
-        </p:nvSpPr>
-        <p:spPr>
-          <a:xfrm>
-            <a:off x="3429000" y="1047750"/>
-            <a:ext cx="3429000" cy="4191000"/>
-          </a:xfrm>
-          <a:prstGeom prst="rect">
-            <a:avLst/>
-          </a:prstGeom>
-          <a:noFill/>
-        </p:spPr>
-        <p:txBody>
-          <a:bodyPr wrap="square" lIns="0" rIns="0" tIns="0" bIns="0" anchor="ctr">
-            <a:spAutoFit/>
-          </a:bodyPr>
-          <a:lstStyle/>
-          <a:p>
-            <a:pPr algn="ctr"/>
-            <a:r>
-              <a:rPr sz="3000" b="1" i="0">
-                <a:solidFill>
-                  <a:srgbClr val="22371F"/>
-                </a:solidFill>
-                <a:latin typeface="Montserrat"/>
-              </a:rPr>
-              <a:t>[PHOTO: Dr. Carla Portugal]</a:t>
-            </a:r>
-          </a:p>
-        </p:txBody>
-      </p:sp>
-      <p:sp>
-        <p:nvSpPr>
-          <p:cNvPr id="5" name="TextBox 4"/>
-          <p:cNvSpPr txBox="1"/>
-          <p:nvPr/>
-        </p:nvSpPr>
-        <p:spPr>
-          <a:xfrm>
-            <a:off x="762000" y="5905500"/>
-            <a:ext cx="8763000" cy="762000"/>
-          </a:xfrm>
-          <a:prstGeom prst="rect">
-            <a:avLst/>
-          </a:prstGeom>
-          <a:noFill/>
-        </p:spPr>
-        <p:txBody>
-          <a:bodyPr wrap="square" lIns="0" rIns="0" tIns="0" bIns="0" anchor="t">
-            <a:spAutoFit/>
-          </a:bodyPr>
-          <a:lstStyle/>
-          <a:p>
-            <a:pPr algn="ctr"/>
-            <a:r>
-              <a:rPr sz="4800" b="1" i="0">
-                <a:solidFill>
-                  <a:srgbClr val="22371F"/>
-                </a:solidFill>
-                <a:latin typeface="Montserrat"/>
-              </a:rPr>
-              <a:t>Dr. Carla Portugal</a:t>
-            </a:r>
-          </a:p>
-        </p:txBody>
-      </p:sp>
-      <p:sp>
-        <p:nvSpPr>
-          <p:cNvPr id="6" name="TextBox 5"/>
-          <p:cNvSpPr txBox="1"/>
-          <p:nvPr/>
-        </p:nvSpPr>
-        <p:spPr>
-          <a:xfrm>
-            <a:off x="762000" y="6715125"/>
-            <a:ext cx="8763000" cy="571500"/>
-          </a:xfrm>
-          <a:prstGeom prst="rect">
-            <a:avLst/>
-          </a:prstGeom>
-          <a:noFill/>
-        </p:spPr>
-        <p:txBody>
-          <a:bodyPr wrap="square" lIns="0" rIns="0" tIns="0" bIns="0" anchor="t">
-            <a:spAutoFit/>
-          </a:bodyPr>
-          <a:lstStyle/>
-          <a:p>
-            <a:pPr algn="ctr"/>
-            <a:r>
-              <a:rPr sz="3300" b="0" i="0">
-                <a:solidFill>
-                  <a:srgbClr val="156826"/>
-                </a:solidFill>
-                <a:latin typeface="Source Sans 3"/>
-              </a:rPr>
-              <a:t>Science Leader</a:t>
-            </a:r>
-          </a:p>
-        </p:txBody>
-      </p:sp>
-      <p:sp>
-        <p:nvSpPr>
-          <p:cNvPr id="7" name="TextBox 6"/>
-          <p:cNvSpPr txBox="1"/>
-          <p:nvPr/>
-        </p:nvSpPr>
-        <p:spPr>
-          <a:xfrm>
-            <a:off x="762000" y="7620000"/>
-            <a:ext cx="8763000" cy="3619500"/>
-          </a:xfrm>
-          <a:prstGeom prst="rect">
-            <a:avLst/>
-          </a:prstGeom>
-          <a:noFill/>
-        </p:spPr>
-        <p:txBody>
-          <a:bodyPr wrap="square" lIns="0" rIns="0" tIns="0" bIns="0" anchor="t">
-            <a:spAutoFit/>
-          </a:bodyPr>
-          <a:lstStyle/>
-          <a:p>
-            <a:pPr algn="ctr"/>
-            <a:r>
-              <a:rPr sz="5700" b="0" i="0">
-                <a:solidFill>
-                  <a:srgbClr val="22371F"/>
-                </a:solidFill>
-                <a:latin typeface="Source Sans 3"/>
-              </a:rPr>
-              <a:t>[COPY: Allison] “[PLACEHOLDER tip]”</a:t>
-            </a:r>
-          </a:p>
-        </p:txBody>
-      </p:sp>
-      <p:sp>
-        <p:nvSpPr>
-          <p:cNvPr id="8" name="TextBox 7"/>
-          <p:cNvSpPr txBox="1"/>
-          <p:nvPr/>
-        </p:nvSpPr>
-        <p:spPr>
-          <a:xfrm>
-            <a:off x="571500" y="12192000"/>
-            <a:ext cx="9144000" cy="342900"/>
-          </a:xfrm>
-          <a:prstGeom prst="rect">
-            <a:avLst/>
-          </a:prstGeom>
-          <a:noFill/>
-        </p:spPr>
-        <p:txBody>
-          <a:bodyPr wrap="square" lIns="0" rIns="0" tIns="0" bIns="0" anchor="t">
-            <a:spAutoFit/>
-          </a:bodyPr>
-          <a:lstStyle/>
-          <a:p>
-            <a:pPr algn="l"/>
-            <a:r>
-              <a:rPr sz="3000" b="1" i="0">
-                <a:solidFill>
-                  <a:srgbClr val="6A665C"/>
-                </a:solidFill>
-                <a:latin typeface="Montserrat"/>
-              </a:rPr>
-              <a:t>@soilfoodwebschool</a:t>
-            </a:r>
-          </a:p>
-        </p:txBody>
-      </p:sp>
-      <p:sp>
-        <p:nvSpPr>
           <p:cNvPr id="9" name="Oval 8"/>
           <p:cNvSpPr/>
           <p:nvPr/>
         </p:nvSpPr>
         <p:spPr>
           <a:xfrm>
-            <a:off x="7715250" y="12363450"/>
+            <a:off x="8001000" y="12363450"/>
+            <a:ext cx="152400" cy="152400"/>
+          </a:xfrm>
+          <a:prstGeom prst="ellipse">
+            <a:avLst/>
+          </a:prstGeom>
+          <a:solidFill>
+            <a:srgbClr val="156826"/>
+          </a:solidFill>
+          <a:ln>
+            <a:noFill/>
+          </a:ln>
+          <a:effectLst/>
+        </p:spPr>
+        <p:style>
+          <a:lnRef idx="1">
+            <a:schemeClr val="accent1"/>
+          </a:lnRef>
+          <a:fillRef idx="3">
+            <a:schemeClr val="accent1"/>
+          </a:fillRef>
+          <a:effectRef idx="2">
+            <a:schemeClr val="accent1"/>
+          </a:effectRef>
+          <a:fontRef idx="minor">
+            <a:schemeClr val="lt1"/>
+          </a:fontRef>
+        </p:style>
+        <p:txBody>
+          <a:bodyPr rtlCol="0" anchor="ctr"/>
+          <a:lstStyle/>
+          <a:p>
+            <a:pPr algn="ctr"/>
+          </a:p>
+        </p:txBody>
+      </p:sp>
+      <p:sp>
+        <p:nvSpPr>
+          <p:cNvPr id="10" name="Oval 9"/>
+          <p:cNvSpPr/>
+          <p:nvPr/>
+        </p:nvSpPr>
+        <p:spPr>
+          <a:xfrm>
+            <a:off x="8286750" y="12363450"/>
             <a:ext cx="152400" cy="152400"/>
           </a:xfrm>
           <a:prstGeom prst="ellipse">
@@ -4805,57 +4838,13 @@
       </p:sp>
       <p:sp>
         <p:nvSpPr>
-          <p:cNvPr id="10" name="Oval 9"/>
-          <p:cNvSpPr/>
-          <p:nvPr/>
-        </p:nvSpPr>
-        <p:spPr>
-          <a:xfrm>
-            <a:off x="8001000" y="12363450"/>
-            <a:ext cx="152400" cy="152400"/>
-          </a:xfrm>
-          <a:prstGeom prst="ellipse">
-            <a:avLst/>
-          </a:prstGeom>
-          <a:solidFill>
-            <a:srgbClr val="156826"/>
-          </a:solidFill>
-          <a:ln>
-            <a:noFill/>
-          </a:ln>
-          <a:effectLst/>
-        </p:spPr>
-        <p:style>
-          <a:lnRef idx="1">
-            <a:schemeClr val="accent1"/>
-          </a:lnRef>
-          <a:fillRef idx="3">
-            <a:schemeClr val="accent1"/>
-          </a:fillRef>
-          <a:effectRef idx="2">
-            <a:schemeClr val="accent1"/>
-          </a:effectRef>
-          <a:fontRef idx="minor">
-            <a:schemeClr val="lt1"/>
-          </a:fontRef>
-        </p:style>
-        <p:txBody>
-          <a:bodyPr rtlCol="0" anchor="ctr"/>
-          <a:lstStyle/>
-          <a:p>
-            <a:pPr algn="ctr"/>
-          </a:p>
-        </p:txBody>
-      </p:sp>
-      <p:sp>
-        <p:nvSpPr>
           <p:cNvPr id="11" name="Oval 10"/>
           <p:cNvSpPr/>
           <p:nvPr/>
         </p:nvSpPr>
         <p:spPr>
           <a:xfrm>
-            <a:off x="8286750" y="12363450"/>
+            <a:off x="8572500" y="12363450"/>
             <a:ext cx="152400" cy="152400"/>
           </a:xfrm>
           <a:prstGeom prst="ellipse">
@@ -4899,7 +4888,7 @@
         </p:nvSpPr>
         <p:spPr>
           <a:xfrm>
-            <a:off x="8572500" y="12363450"/>
+            <a:off x="8858250" y="12363450"/>
             <a:ext cx="152400" cy="152400"/>
           </a:xfrm>
           <a:prstGeom prst="ellipse">
@@ -4943,7 +4932,7 @@
         </p:nvSpPr>
         <p:spPr>
           <a:xfrm>
-            <a:off x="8858250" y="12363450"/>
+            <a:off x="9144000" y="12363450"/>
             <a:ext cx="152400" cy="152400"/>
           </a:xfrm>
           <a:prstGeom prst="ellipse">
@@ -4982,50 +4971,6 @@
       <p:sp>
         <p:nvSpPr>
           <p:cNvPr id="14" name="Oval 13"/>
-          <p:cNvSpPr/>
-          <p:nvPr/>
-        </p:nvSpPr>
-        <p:spPr>
-          <a:xfrm>
-            <a:off x="9144000" y="12363450"/>
-            <a:ext cx="152400" cy="152400"/>
-          </a:xfrm>
-          <a:prstGeom prst="ellipse">
-            <a:avLst/>
-          </a:prstGeom>
-          <a:solidFill>
-            <a:srgbClr val="A7B097"/>
-          </a:solidFill>
-          <a:ln>
-            <a:noFill/>
-          </a:ln>
-          <a:effectLst/>
-        </p:spPr>
-        <p:style>
-          <a:lnRef idx="1">
-            <a:schemeClr val="accent1"/>
-          </a:lnRef>
-          <a:fillRef idx="3">
-            <a:schemeClr val="accent1"/>
-          </a:fillRef>
-          <a:effectRef idx="2">
-            <a:schemeClr val="accent1"/>
-          </a:effectRef>
-          <a:fontRef idx="minor">
-            <a:schemeClr val="lt1"/>
-          </a:fontRef>
-        </p:style>
-        <p:txBody>
-          <a:bodyPr rtlCol="0" anchor="ctr"/>
-          <a:lstStyle/>
-          <a:p>
-            <a:pPr algn="ctr"/>
-          </a:p>
-        </p:txBody>
-      </p:sp>
-      <p:sp>
-        <p:nvSpPr>
-          <p:cNvPr id="15" name="Oval 14"/>
           <p:cNvSpPr/>
           <p:nvPr/>
         </p:nvSpPr>
@@ -5137,16 +5082,180 @@
           </a:p>
         </p:txBody>
       </p:sp>
-      <p:sp>
-        <p:nvSpPr>
-          <p:cNvPr id="3" name="Oval 2"/>
-          <p:cNvSpPr/>
-          <p:nvPr/>
-        </p:nvSpPr>
+      <p:pic>
+        <p:nvPicPr>
+          <p:cNvPr id="3" name="Picture 2" descr=".circle-440.png"/>
+          <p:cNvPicPr>
+            <a:picLocks noChangeAspect="1"/>
+          </p:cNvPicPr>
+          <p:nvPr/>
+        </p:nvPicPr>
+        <p:blipFill>
+          <a:blip r:embed="rId3"/>
+          <a:stretch>
+            <a:fillRect/>
+          </a:stretch>
+        </p:blipFill>
         <p:spPr>
           <a:xfrm>
             <a:off x="3048000" y="1047750"/>
             <a:ext cx="4191000" cy="4191000"/>
+          </a:xfrm>
+          <a:prstGeom prst="rect">
+            <a:avLst/>
+          </a:prstGeom>
+        </p:spPr>
+      </p:pic>
+      <p:sp>
+        <p:nvSpPr>
+          <p:cNvPr id="4" name="TextBox 3"/>
+          <p:cNvSpPr txBox="1"/>
+          <p:nvPr/>
+        </p:nvSpPr>
+        <p:spPr>
+          <a:xfrm>
+            <a:off x="762000" y="5905500"/>
+            <a:ext cx="8763000" cy="762000"/>
+          </a:xfrm>
+          <a:prstGeom prst="rect">
+            <a:avLst/>
+          </a:prstGeom>
+          <a:noFill/>
+        </p:spPr>
+        <p:txBody>
+          <a:bodyPr wrap="square" lIns="0" rIns="0" tIns="0" bIns="0" anchor="t">
+            <a:spAutoFit/>
+          </a:bodyPr>
+          <a:lstStyle/>
+          <a:p>
+            <a:pPr algn="ctr"/>
+            <a:r>
+              <a:rPr sz="4800" b="1" i="0">
+                <a:solidFill>
+                  <a:srgbClr val="22371F"/>
+                </a:solidFill>
+                <a:latin typeface="Montserrat"/>
+              </a:rPr>
+              <a:t>Nick Padwick</a:t>
+            </a:r>
+          </a:p>
+        </p:txBody>
+      </p:sp>
+      <p:sp>
+        <p:nvSpPr>
+          <p:cNvPr id="5" name="TextBox 4"/>
+          <p:cNvSpPr txBox="1"/>
+          <p:nvPr/>
+        </p:nvSpPr>
+        <p:spPr>
+          <a:xfrm>
+            <a:off x="762000" y="6715125"/>
+            <a:ext cx="8763000" cy="571500"/>
+          </a:xfrm>
+          <a:prstGeom prst="rect">
+            <a:avLst/>
+          </a:prstGeom>
+          <a:noFill/>
+        </p:spPr>
+        <p:txBody>
+          <a:bodyPr wrap="square" lIns="0" rIns="0" tIns="0" bIns="0" anchor="t">
+            <a:spAutoFit/>
+          </a:bodyPr>
+          <a:lstStyle/>
+          <a:p>
+            <a:pPr algn="ctr"/>
+            <a:r>
+              <a:rPr sz="3300" b="0" i="0">
+                <a:solidFill>
+                  <a:srgbClr val="156826"/>
+                </a:solidFill>
+                <a:latin typeface="Source Sans 3"/>
+              </a:rPr>
+              <a:t>Farmer, Norfolk</a:t>
+            </a:r>
+          </a:p>
+        </p:txBody>
+      </p:sp>
+      <p:sp>
+        <p:nvSpPr>
+          <p:cNvPr id="6" name="TextBox 5"/>
+          <p:cNvSpPr txBox="1"/>
+          <p:nvPr/>
+        </p:nvSpPr>
+        <p:spPr>
+          <a:xfrm>
+            <a:off x="762000" y="7620000"/>
+            <a:ext cx="8763000" cy="3619500"/>
+          </a:xfrm>
+          <a:prstGeom prst="rect">
+            <a:avLst/>
+          </a:prstGeom>
+          <a:noFill/>
+        </p:spPr>
+        <p:txBody>
+          <a:bodyPr wrap="square" lIns="0" rIns="0" tIns="0" bIns="0" anchor="t">
+            <a:spAutoFit/>
+          </a:bodyPr>
+          <a:lstStyle/>
+          <a:p>
+            <a:pPr algn="ctr"/>
+            <a:r>
+              <a:rPr sz="5700" b="0" i="0">
+                <a:solidFill>
+                  <a:srgbClr val="22371F"/>
+                </a:solidFill>
+                <a:latin typeface="Source Sans 3"/>
+              </a:rPr>
+              <a:t>[COPY: Allison] “[PLACEHOLDER tip]”</a:t>
+            </a:r>
+          </a:p>
+        </p:txBody>
+      </p:sp>
+      <p:sp>
+        <p:nvSpPr>
+          <p:cNvPr id="7" name="TextBox 6"/>
+          <p:cNvSpPr txBox="1"/>
+          <p:nvPr/>
+        </p:nvSpPr>
+        <p:spPr>
+          <a:xfrm>
+            <a:off x="571500" y="12192000"/>
+            <a:ext cx="9144000" cy="342900"/>
+          </a:xfrm>
+          <a:prstGeom prst="rect">
+            <a:avLst/>
+          </a:prstGeom>
+          <a:noFill/>
+        </p:spPr>
+        <p:txBody>
+          <a:bodyPr wrap="square" lIns="0" rIns="0" tIns="0" bIns="0" anchor="t">
+            <a:spAutoFit/>
+          </a:bodyPr>
+          <a:lstStyle/>
+          <a:p>
+            <a:pPr algn="l"/>
+            <a:r>
+              <a:rPr sz="3000" b="1" i="0">
+                <a:solidFill>
+                  <a:srgbClr val="6A665C"/>
+                </a:solidFill>
+                <a:latin typeface="Montserrat"/>
+              </a:rPr>
+              <a:t>@soilfoodwebschool</a:t>
+            </a:r>
+          </a:p>
+        </p:txBody>
+      </p:sp>
+      <p:sp>
+        <p:nvSpPr>
+          <p:cNvPr id="8" name="Oval 7"/>
+          <p:cNvSpPr/>
+          <p:nvPr/>
+        </p:nvSpPr>
+        <p:spPr>
+          <a:xfrm>
+            <a:off x="7715250" y="12363450"/>
+            <a:ext cx="152400" cy="152400"/>
           </a:xfrm>
           <a:prstGeom prst="ellipse">
             <a:avLst/>
@@ -5183,188 +5292,13 @@
       </p:sp>
       <p:sp>
         <p:nvSpPr>
-          <p:cNvPr id="4" name="TextBox 3"/>
-          <p:cNvSpPr txBox="1"/>
-          <p:nvPr/>
-        </p:nvSpPr>
-        <p:spPr>
-          <a:xfrm>
-            <a:off x="3429000" y="1047750"/>
-            <a:ext cx="3429000" cy="4191000"/>
-          </a:xfrm>
-          <a:prstGeom prst="rect">
-            <a:avLst/>
-          </a:prstGeom>
-          <a:noFill/>
-        </p:spPr>
-        <p:txBody>
-          <a:bodyPr wrap="square" lIns="0" rIns="0" tIns="0" bIns="0" anchor="ctr">
-            <a:spAutoFit/>
-          </a:bodyPr>
-          <a:lstStyle/>
-          <a:p>
-            <a:pPr algn="ctr"/>
-            <a:r>
-              <a:rPr sz="3000" b="1" i="0">
-                <a:solidFill>
-                  <a:srgbClr val="22371F"/>
-                </a:solidFill>
-                <a:latin typeface="Montserrat"/>
-              </a:rPr>
-              <a:t>[PHOTO: Nick Padwick]</a:t>
-            </a:r>
-          </a:p>
-        </p:txBody>
-      </p:sp>
-      <p:sp>
-        <p:nvSpPr>
-          <p:cNvPr id="5" name="TextBox 4"/>
-          <p:cNvSpPr txBox="1"/>
-          <p:nvPr/>
-        </p:nvSpPr>
-        <p:spPr>
-          <a:xfrm>
-            <a:off x="762000" y="5905500"/>
-            <a:ext cx="8763000" cy="762000"/>
-          </a:xfrm>
-          <a:prstGeom prst="rect">
-            <a:avLst/>
-          </a:prstGeom>
-          <a:noFill/>
-        </p:spPr>
-        <p:txBody>
-          <a:bodyPr wrap="square" lIns="0" rIns="0" tIns="0" bIns="0" anchor="t">
-            <a:spAutoFit/>
-          </a:bodyPr>
-          <a:lstStyle/>
-          <a:p>
-            <a:pPr algn="ctr"/>
-            <a:r>
-              <a:rPr sz="4800" b="1" i="0">
-                <a:solidFill>
-                  <a:srgbClr val="22371F"/>
-                </a:solidFill>
-                <a:latin typeface="Montserrat"/>
-              </a:rPr>
-              <a:t>Nick Padwick</a:t>
-            </a:r>
-          </a:p>
-        </p:txBody>
-      </p:sp>
-      <p:sp>
-        <p:nvSpPr>
-          <p:cNvPr id="6" name="TextBox 5"/>
-          <p:cNvSpPr txBox="1"/>
-          <p:nvPr/>
-        </p:nvSpPr>
-        <p:spPr>
-          <a:xfrm>
-            <a:off x="762000" y="6715125"/>
-            <a:ext cx="8763000" cy="571500"/>
-          </a:xfrm>
-          <a:prstGeom prst="rect">
-            <a:avLst/>
-          </a:prstGeom>
-          <a:noFill/>
-        </p:spPr>
-        <p:txBody>
-          <a:bodyPr wrap="square" lIns="0" rIns="0" tIns="0" bIns="0" anchor="t">
-            <a:spAutoFit/>
-          </a:bodyPr>
-          <a:lstStyle/>
-          <a:p>
-            <a:pPr algn="ctr"/>
-            <a:r>
-              <a:rPr sz="3300" b="0" i="0">
-                <a:solidFill>
-                  <a:srgbClr val="156826"/>
-                </a:solidFill>
-                <a:latin typeface="Source Sans 3"/>
-              </a:rPr>
-              <a:t>Farmer, Norfolk</a:t>
-            </a:r>
-          </a:p>
-        </p:txBody>
-      </p:sp>
-      <p:sp>
-        <p:nvSpPr>
-          <p:cNvPr id="7" name="TextBox 6"/>
-          <p:cNvSpPr txBox="1"/>
-          <p:nvPr/>
-        </p:nvSpPr>
-        <p:spPr>
-          <a:xfrm>
-            <a:off x="762000" y="7620000"/>
-            <a:ext cx="8763000" cy="3619500"/>
-          </a:xfrm>
-          <a:prstGeom prst="rect">
-            <a:avLst/>
-          </a:prstGeom>
-          <a:noFill/>
-        </p:spPr>
-        <p:txBody>
-          <a:bodyPr wrap="square" lIns="0" rIns="0" tIns="0" bIns="0" anchor="t">
-            <a:spAutoFit/>
-          </a:bodyPr>
-          <a:lstStyle/>
-          <a:p>
-            <a:pPr algn="ctr"/>
-            <a:r>
-              <a:rPr sz="5700" b="0" i="0">
-                <a:solidFill>
-                  <a:srgbClr val="22371F"/>
-                </a:solidFill>
-                <a:latin typeface="Source Sans 3"/>
-              </a:rPr>
-              <a:t>[COPY: Allison] “[PLACEHOLDER tip]”</a:t>
-            </a:r>
-          </a:p>
-        </p:txBody>
-      </p:sp>
-      <p:sp>
-        <p:nvSpPr>
-          <p:cNvPr id="8" name="TextBox 7"/>
-          <p:cNvSpPr txBox="1"/>
-          <p:nvPr/>
-        </p:nvSpPr>
-        <p:spPr>
-          <a:xfrm>
-            <a:off x="571500" y="12192000"/>
-            <a:ext cx="9144000" cy="342900"/>
-          </a:xfrm>
-          <a:prstGeom prst="rect">
-            <a:avLst/>
-          </a:prstGeom>
-          <a:noFill/>
-        </p:spPr>
-        <p:txBody>
-          <a:bodyPr wrap="square" lIns="0" rIns="0" tIns="0" bIns="0" anchor="t">
-            <a:spAutoFit/>
-          </a:bodyPr>
-          <a:lstStyle/>
-          <a:p>
-            <a:pPr algn="l"/>
-            <a:r>
-              <a:rPr sz="3000" b="1" i="0">
-                <a:solidFill>
-                  <a:srgbClr val="6A665C"/>
-                </a:solidFill>
-                <a:latin typeface="Montserrat"/>
-              </a:rPr>
-              <a:t>@soilfoodwebschool</a:t>
-            </a:r>
-          </a:p>
-        </p:txBody>
-      </p:sp>
-      <p:sp>
-        <p:nvSpPr>
           <p:cNvPr id="9" name="Oval 8"/>
           <p:cNvSpPr/>
           <p:nvPr/>
         </p:nvSpPr>
         <p:spPr>
           <a:xfrm>
-            <a:off x="7715250" y="12363450"/>
+            <a:off x="8001000" y="12363450"/>
             <a:ext cx="152400" cy="152400"/>
           </a:xfrm>
           <a:prstGeom prst="ellipse">
@@ -5408,7 +5342,51 @@
         </p:nvSpPr>
         <p:spPr>
           <a:xfrm>
-            <a:off x="8001000" y="12363450"/>
+            <a:off x="8286750" y="12363450"/>
+            <a:ext cx="152400" cy="152400"/>
+          </a:xfrm>
+          <a:prstGeom prst="ellipse">
+            <a:avLst/>
+          </a:prstGeom>
+          <a:solidFill>
+            <a:srgbClr val="156826"/>
+          </a:solidFill>
+          <a:ln>
+            <a:noFill/>
+          </a:ln>
+          <a:effectLst/>
+        </p:spPr>
+        <p:style>
+          <a:lnRef idx="1">
+            <a:schemeClr val="accent1"/>
+          </a:lnRef>
+          <a:fillRef idx="3">
+            <a:schemeClr val="accent1"/>
+          </a:fillRef>
+          <a:effectRef idx="2">
+            <a:schemeClr val="accent1"/>
+          </a:effectRef>
+          <a:fontRef idx="minor">
+            <a:schemeClr val="lt1"/>
+          </a:fontRef>
+        </p:style>
+        <p:txBody>
+          <a:bodyPr rtlCol="0" anchor="ctr"/>
+          <a:lstStyle/>
+          <a:p>
+            <a:pPr algn="ctr"/>
+          </a:p>
+        </p:txBody>
+      </p:sp>
+      <p:sp>
+        <p:nvSpPr>
+          <p:cNvPr id="11" name="Oval 10"/>
+          <p:cNvSpPr/>
+          <p:nvPr/>
+        </p:nvSpPr>
+        <p:spPr>
+          <a:xfrm>
+            <a:off x="8572500" y="12363450"/>
             <a:ext cx="152400" cy="152400"/>
           </a:xfrm>
           <a:prstGeom prst="ellipse">
@@ -5446,57 +5424,13 @@
       </p:sp>
       <p:sp>
         <p:nvSpPr>
-          <p:cNvPr id="11" name="Oval 10"/>
-          <p:cNvSpPr/>
-          <p:nvPr/>
-        </p:nvSpPr>
-        <p:spPr>
-          <a:xfrm>
-            <a:off x="8286750" y="12363450"/>
-            <a:ext cx="152400" cy="152400"/>
-          </a:xfrm>
-          <a:prstGeom prst="ellipse">
-            <a:avLst/>
-          </a:prstGeom>
-          <a:solidFill>
-            <a:srgbClr val="156826"/>
-          </a:solidFill>
-          <a:ln>
-            <a:noFill/>
-          </a:ln>
-          <a:effectLst/>
-        </p:spPr>
-        <p:style>
-          <a:lnRef idx="1">
-            <a:schemeClr val="accent1"/>
-          </a:lnRef>
-          <a:fillRef idx="3">
-            <a:schemeClr val="accent1"/>
-          </a:fillRef>
-          <a:effectRef idx="2">
-            <a:schemeClr val="accent1"/>
-          </a:effectRef>
-          <a:fontRef idx="minor">
-            <a:schemeClr val="lt1"/>
-          </a:fontRef>
-        </p:style>
-        <p:txBody>
-          <a:bodyPr rtlCol="0" anchor="ctr"/>
-          <a:lstStyle/>
-          <a:p>
-            <a:pPr algn="ctr"/>
-          </a:p>
-        </p:txBody>
-      </p:sp>
-      <p:sp>
-        <p:nvSpPr>
           <p:cNvPr id="12" name="Oval 11"/>
           <p:cNvSpPr/>
           <p:nvPr/>
         </p:nvSpPr>
         <p:spPr>
           <a:xfrm>
-            <a:off x="8572500" y="12363450"/>
+            <a:off x="8858250" y="12363450"/>
             <a:ext cx="152400" cy="152400"/>
           </a:xfrm>
           <a:prstGeom prst="ellipse">
@@ -5540,7 +5474,7 @@
         </p:nvSpPr>
         <p:spPr>
           <a:xfrm>
-            <a:off x="8858250" y="12363450"/>
+            <a:off x="9144000" y="12363450"/>
             <a:ext cx="152400" cy="152400"/>
           </a:xfrm>
           <a:prstGeom prst="ellipse">
@@ -5579,50 +5513,6 @@
       <p:sp>
         <p:nvSpPr>
           <p:cNvPr id="14" name="Oval 13"/>
-          <p:cNvSpPr/>
-          <p:nvPr/>
-        </p:nvSpPr>
-        <p:spPr>
-          <a:xfrm>
-            <a:off x="9144000" y="12363450"/>
-            <a:ext cx="152400" cy="152400"/>
-          </a:xfrm>
-          <a:prstGeom prst="ellipse">
-            <a:avLst/>
-          </a:prstGeom>
-          <a:solidFill>
-            <a:srgbClr val="A7B097"/>
-          </a:solidFill>
-          <a:ln>
-            <a:noFill/>
-          </a:ln>
-          <a:effectLst/>
-        </p:spPr>
-        <p:style>
-          <a:lnRef idx="1">
-            <a:schemeClr val="accent1"/>
-          </a:lnRef>
-          <a:fillRef idx="3">
-            <a:schemeClr val="accent1"/>
-          </a:fillRef>
-          <a:effectRef idx="2">
-            <a:schemeClr val="accent1"/>
-          </a:effectRef>
-          <a:fontRef idx="minor">
-            <a:schemeClr val="lt1"/>
-          </a:fontRef>
-        </p:style>
-        <p:txBody>
-          <a:bodyPr rtlCol="0" anchor="ctr"/>
-          <a:lstStyle/>
-          <a:p>
-            <a:pPr algn="ctr"/>
-          </a:p>
-        </p:txBody>
-      </p:sp>
-      <p:sp>
-        <p:nvSpPr>
-          <p:cNvPr id="15" name="Oval 14"/>
           <p:cNvSpPr/>
           <p:nvPr/>
         </p:nvSpPr>
@@ -5734,16 +5624,180 @@
           </a:p>
         </p:txBody>
       </p:sp>
-      <p:sp>
-        <p:nvSpPr>
-          <p:cNvPr id="3" name="Oval 2"/>
-          <p:cNvSpPr/>
-          <p:nvPr/>
-        </p:nvSpPr>
+      <p:pic>
+        <p:nvPicPr>
+          <p:cNvPr id="3" name="Picture 2" descr=".circle-440.png"/>
+          <p:cNvPicPr>
+            <a:picLocks noChangeAspect="1"/>
+          </p:cNvPicPr>
+          <p:nvPr/>
+        </p:nvPicPr>
+        <p:blipFill>
+          <a:blip r:embed="rId3"/>
+          <a:stretch>
+            <a:fillRect/>
+          </a:stretch>
+        </p:blipFill>
         <p:spPr>
           <a:xfrm>
             <a:off x="3048000" y="1047750"/>
             <a:ext cx="4191000" cy="4191000"/>
+          </a:xfrm>
+          <a:prstGeom prst="rect">
+            <a:avLst/>
+          </a:prstGeom>
+        </p:spPr>
+      </p:pic>
+      <p:sp>
+        <p:nvSpPr>
+          <p:cNvPr id="4" name="TextBox 3"/>
+          <p:cNvSpPr txBox="1"/>
+          <p:nvPr/>
+        </p:nvSpPr>
+        <p:spPr>
+          <a:xfrm>
+            <a:off x="762000" y="5905500"/>
+            <a:ext cx="8763000" cy="762000"/>
+          </a:xfrm>
+          <a:prstGeom prst="rect">
+            <a:avLst/>
+          </a:prstGeom>
+          <a:noFill/>
+        </p:spPr>
+        <p:txBody>
+          <a:bodyPr wrap="square" lIns="0" rIns="0" tIns="0" bIns="0" anchor="t">
+            <a:spAutoFit/>
+          </a:bodyPr>
+          <a:lstStyle/>
+          <a:p>
+            <a:pPr algn="ctr"/>
+            <a:r>
+              <a:rPr sz="4800" b="1" i="0">
+                <a:solidFill>
+                  <a:srgbClr val="22371F"/>
+                </a:solidFill>
+                <a:latin typeface="Montserrat"/>
+              </a:rPr>
+              <a:t>Wes Sander</a:t>
+            </a:r>
+          </a:p>
+        </p:txBody>
+      </p:sp>
+      <p:sp>
+        <p:nvSpPr>
+          <p:cNvPr id="5" name="TextBox 4"/>
+          <p:cNvSpPr txBox="1"/>
+          <p:nvPr/>
+        </p:nvSpPr>
+        <p:spPr>
+          <a:xfrm>
+            <a:off x="762000" y="6715125"/>
+            <a:ext cx="8763000" cy="571500"/>
+          </a:xfrm>
+          <a:prstGeom prst="rect">
+            <a:avLst/>
+          </a:prstGeom>
+          <a:noFill/>
+        </p:spPr>
+        <p:txBody>
+          <a:bodyPr wrap="square" lIns="0" rIns="0" tIns="0" bIns="0" anchor="t">
+            <a:spAutoFit/>
+          </a:bodyPr>
+          <a:lstStyle/>
+          <a:p>
+            <a:pPr algn="ctr"/>
+            <a:r>
+              <a:rPr sz="3300" b="0" i="0">
+                <a:solidFill>
+                  <a:srgbClr val="156826"/>
+                </a:solidFill>
+                <a:latin typeface="Source Sans 3"/>
+              </a:rPr>
+              <a:t>Microscopy</a:t>
+            </a:r>
+          </a:p>
+        </p:txBody>
+      </p:sp>
+      <p:sp>
+        <p:nvSpPr>
+          <p:cNvPr id="6" name="TextBox 5"/>
+          <p:cNvSpPr txBox="1"/>
+          <p:nvPr/>
+        </p:nvSpPr>
+        <p:spPr>
+          <a:xfrm>
+            <a:off x="762000" y="7620000"/>
+            <a:ext cx="8763000" cy="3619500"/>
+          </a:xfrm>
+          <a:prstGeom prst="rect">
+            <a:avLst/>
+          </a:prstGeom>
+          <a:noFill/>
+        </p:spPr>
+        <p:txBody>
+          <a:bodyPr wrap="square" lIns="0" rIns="0" tIns="0" bIns="0" anchor="t">
+            <a:spAutoFit/>
+          </a:bodyPr>
+          <a:lstStyle/>
+          <a:p>
+            <a:pPr algn="ctr"/>
+            <a:r>
+              <a:rPr sz="5700" b="0" i="0">
+                <a:solidFill>
+                  <a:srgbClr val="22371F"/>
+                </a:solidFill>
+                <a:latin typeface="Source Sans 3"/>
+              </a:rPr>
+              <a:t>[COPY: Allison] “[PLACEHOLDER tip]”</a:t>
+            </a:r>
+          </a:p>
+        </p:txBody>
+      </p:sp>
+      <p:sp>
+        <p:nvSpPr>
+          <p:cNvPr id="7" name="TextBox 6"/>
+          <p:cNvSpPr txBox="1"/>
+          <p:nvPr/>
+        </p:nvSpPr>
+        <p:spPr>
+          <a:xfrm>
+            <a:off x="571500" y="12192000"/>
+            <a:ext cx="9144000" cy="342900"/>
+          </a:xfrm>
+          <a:prstGeom prst="rect">
+            <a:avLst/>
+          </a:prstGeom>
+          <a:noFill/>
+        </p:spPr>
+        <p:txBody>
+          <a:bodyPr wrap="square" lIns="0" rIns="0" tIns="0" bIns="0" anchor="t">
+            <a:spAutoFit/>
+          </a:bodyPr>
+          <a:lstStyle/>
+          <a:p>
+            <a:pPr algn="l"/>
+            <a:r>
+              <a:rPr sz="3000" b="1" i="0">
+                <a:solidFill>
+                  <a:srgbClr val="6A665C"/>
+                </a:solidFill>
+                <a:latin typeface="Montserrat"/>
+              </a:rPr>
+              <a:t>@soilfoodwebschool</a:t>
+            </a:r>
+          </a:p>
+        </p:txBody>
+      </p:sp>
+      <p:sp>
+        <p:nvSpPr>
+          <p:cNvPr id="8" name="Oval 7"/>
+          <p:cNvSpPr/>
+          <p:nvPr/>
+        </p:nvSpPr>
+        <p:spPr>
+          <a:xfrm>
+            <a:off x="7715250" y="12363450"/>
+            <a:ext cx="152400" cy="152400"/>
           </a:xfrm>
           <a:prstGeom prst="ellipse">
             <a:avLst/>
@@ -5780,188 +5834,13 @@
       </p:sp>
       <p:sp>
         <p:nvSpPr>
-          <p:cNvPr id="4" name="TextBox 3"/>
-          <p:cNvSpPr txBox="1"/>
-          <p:nvPr/>
-        </p:nvSpPr>
-        <p:spPr>
-          <a:xfrm>
-            <a:off x="3429000" y="1047750"/>
-            <a:ext cx="3429000" cy="4191000"/>
-          </a:xfrm>
-          <a:prstGeom prst="rect">
-            <a:avLst/>
-          </a:prstGeom>
-          <a:noFill/>
-        </p:spPr>
-        <p:txBody>
-          <a:bodyPr wrap="square" lIns="0" rIns="0" tIns="0" bIns="0" anchor="ctr">
-            <a:spAutoFit/>
-          </a:bodyPr>
-          <a:lstStyle/>
-          <a:p>
-            <a:pPr algn="ctr"/>
-            <a:r>
-              <a:rPr sz="3000" b="1" i="0">
-                <a:solidFill>
-                  <a:srgbClr val="22371F"/>
-                </a:solidFill>
-                <a:latin typeface="Montserrat"/>
-              </a:rPr>
-              <a:t>[PHOTO: Wes Sander]</a:t>
-            </a:r>
-          </a:p>
-        </p:txBody>
-      </p:sp>
-      <p:sp>
-        <p:nvSpPr>
-          <p:cNvPr id="5" name="TextBox 4"/>
-          <p:cNvSpPr txBox="1"/>
-          <p:nvPr/>
-        </p:nvSpPr>
-        <p:spPr>
-          <a:xfrm>
-            <a:off x="762000" y="5905500"/>
-            <a:ext cx="8763000" cy="762000"/>
-          </a:xfrm>
-          <a:prstGeom prst="rect">
-            <a:avLst/>
-          </a:prstGeom>
-          <a:noFill/>
-        </p:spPr>
-        <p:txBody>
-          <a:bodyPr wrap="square" lIns="0" rIns="0" tIns="0" bIns="0" anchor="t">
-            <a:spAutoFit/>
-          </a:bodyPr>
-          <a:lstStyle/>
-          <a:p>
-            <a:pPr algn="ctr"/>
-            <a:r>
-              <a:rPr sz="4800" b="1" i="0">
-                <a:solidFill>
-                  <a:srgbClr val="22371F"/>
-                </a:solidFill>
-                <a:latin typeface="Montserrat"/>
-              </a:rPr>
-              <a:t>Wes Sander</a:t>
-            </a:r>
-          </a:p>
-        </p:txBody>
-      </p:sp>
-      <p:sp>
-        <p:nvSpPr>
-          <p:cNvPr id="6" name="TextBox 5"/>
-          <p:cNvSpPr txBox="1"/>
-          <p:nvPr/>
-        </p:nvSpPr>
-        <p:spPr>
-          <a:xfrm>
-            <a:off x="762000" y="6715125"/>
-            <a:ext cx="8763000" cy="571500"/>
-          </a:xfrm>
-          <a:prstGeom prst="rect">
-            <a:avLst/>
-          </a:prstGeom>
-          <a:noFill/>
-        </p:spPr>
-        <p:txBody>
-          <a:bodyPr wrap="square" lIns="0" rIns="0" tIns="0" bIns="0" anchor="t">
-            <a:spAutoFit/>
-          </a:bodyPr>
-          <a:lstStyle/>
-          <a:p>
-            <a:pPr algn="ctr"/>
-            <a:r>
-              <a:rPr sz="3300" b="0" i="0">
-                <a:solidFill>
-                  <a:srgbClr val="156826"/>
-                </a:solidFill>
-                <a:latin typeface="Source Sans 3"/>
-              </a:rPr>
-              <a:t>Microscopy</a:t>
-            </a:r>
-          </a:p>
-        </p:txBody>
-      </p:sp>
-      <p:sp>
-        <p:nvSpPr>
-          <p:cNvPr id="7" name="TextBox 6"/>
-          <p:cNvSpPr txBox="1"/>
-          <p:nvPr/>
-        </p:nvSpPr>
-        <p:spPr>
-          <a:xfrm>
-            <a:off x="762000" y="7620000"/>
-            <a:ext cx="8763000" cy="3619500"/>
-          </a:xfrm>
-          <a:prstGeom prst="rect">
-            <a:avLst/>
-          </a:prstGeom>
-          <a:noFill/>
-        </p:spPr>
-        <p:txBody>
-          <a:bodyPr wrap="square" lIns="0" rIns="0" tIns="0" bIns="0" anchor="t">
-            <a:spAutoFit/>
-          </a:bodyPr>
-          <a:lstStyle/>
-          <a:p>
-            <a:pPr algn="ctr"/>
-            <a:r>
-              <a:rPr sz="5700" b="0" i="0">
-                <a:solidFill>
-                  <a:srgbClr val="22371F"/>
-                </a:solidFill>
-                <a:latin typeface="Source Sans 3"/>
-              </a:rPr>
-              <a:t>[COPY: Allison] “[PLACEHOLDER tip]”</a:t>
-            </a:r>
-          </a:p>
-        </p:txBody>
-      </p:sp>
-      <p:sp>
-        <p:nvSpPr>
-          <p:cNvPr id="8" name="TextBox 7"/>
-          <p:cNvSpPr txBox="1"/>
-          <p:nvPr/>
-        </p:nvSpPr>
-        <p:spPr>
-          <a:xfrm>
-            <a:off x="571500" y="12192000"/>
-            <a:ext cx="9144000" cy="342900"/>
-          </a:xfrm>
-          <a:prstGeom prst="rect">
-            <a:avLst/>
-          </a:prstGeom>
-          <a:noFill/>
-        </p:spPr>
-        <p:txBody>
-          <a:bodyPr wrap="square" lIns="0" rIns="0" tIns="0" bIns="0" anchor="t">
-            <a:spAutoFit/>
-          </a:bodyPr>
-          <a:lstStyle/>
-          <a:p>
-            <a:pPr algn="l"/>
-            <a:r>
-              <a:rPr sz="3000" b="1" i="0">
-                <a:solidFill>
-                  <a:srgbClr val="6A665C"/>
-                </a:solidFill>
-                <a:latin typeface="Montserrat"/>
-              </a:rPr>
-              <a:t>@soilfoodwebschool</a:t>
-            </a:r>
-          </a:p>
-        </p:txBody>
-      </p:sp>
-      <p:sp>
-        <p:nvSpPr>
           <p:cNvPr id="9" name="Oval 8"/>
           <p:cNvSpPr/>
           <p:nvPr/>
         </p:nvSpPr>
         <p:spPr>
           <a:xfrm>
-            <a:off x="7715250" y="12363450"/>
+            <a:off x="8001000" y="12363450"/>
             <a:ext cx="152400" cy="152400"/>
           </a:xfrm>
           <a:prstGeom prst="ellipse">
@@ -6005,7 +5884,7 @@
         </p:nvSpPr>
         <p:spPr>
           <a:xfrm>
-            <a:off x="8001000" y="12363450"/>
+            <a:off x="8286750" y="12363450"/>
             <a:ext cx="152400" cy="152400"/>
           </a:xfrm>
           <a:prstGeom prst="ellipse">
@@ -6049,7 +5928,51 @@
         </p:nvSpPr>
         <p:spPr>
           <a:xfrm>
-            <a:off x="8286750" y="12363450"/>
+            <a:off x="8572500" y="12363450"/>
+            <a:ext cx="152400" cy="152400"/>
+          </a:xfrm>
+          <a:prstGeom prst="ellipse">
+            <a:avLst/>
+          </a:prstGeom>
+          <a:solidFill>
+            <a:srgbClr val="156826"/>
+          </a:solidFill>
+          <a:ln>
+            <a:noFill/>
+          </a:ln>
+          <a:effectLst/>
+        </p:spPr>
+        <p:style>
+          <a:lnRef idx="1">
+            <a:schemeClr val="accent1"/>
+          </a:lnRef>
+          <a:fillRef idx="3">
+            <a:schemeClr val="accent1"/>
+          </a:fillRef>
+          <a:effectRef idx="2">
+            <a:schemeClr val="accent1"/>
+          </a:effectRef>
+          <a:fontRef idx="minor">
+            <a:schemeClr val="lt1"/>
+          </a:fontRef>
+        </p:style>
+        <p:txBody>
+          <a:bodyPr rtlCol="0" anchor="ctr"/>
+          <a:lstStyle/>
+          <a:p>
+            <a:pPr algn="ctr"/>
+          </a:p>
+        </p:txBody>
+      </p:sp>
+      <p:sp>
+        <p:nvSpPr>
+          <p:cNvPr id="12" name="Oval 11"/>
+          <p:cNvSpPr/>
+          <p:nvPr/>
+        </p:nvSpPr>
+        <p:spPr>
+          <a:xfrm>
+            <a:off x="8858250" y="12363450"/>
             <a:ext cx="152400" cy="152400"/>
           </a:xfrm>
           <a:prstGeom prst="ellipse">
@@ -6087,57 +6010,13 @@
       </p:sp>
       <p:sp>
         <p:nvSpPr>
-          <p:cNvPr id="12" name="Oval 11"/>
-          <p:cNvSpPr/>
-          <p:nvPr/>
-        </p:nvSpPr>
-        <p:spPr>
-          <a:xfrm>
-            <a:off x="8572500" y="12363450"/>
-            <a:ext cx="152400" cy="152400"/>
-          </a:xfrm>
-          <a:prstGeom prst="ellipse">
-            <a:avLst/>
-          </a:prstGeom>
-          <a:solidFill>
-            <a:srgbClr val="156826"/>
-          </a:solidFill>
-          <a:ln>
-            <a:noFill/>
-          </a:ln>
-          <a:effectLst/>
-        </p:spPr>
-        <p:style>
-          <a:lnRef idx="1">
-            <a:schemeClr val="accent1"/>
-          </a:lnRef>
-          <a:fillRef idx="3">
-            <a:schemeClr val="accent1"/>
-          </a:fillRef>
-          <a:effectRef idx="2">
-            <a:schemeClr val="accent1"/>
-          </a:effectRef>
-          <a:fontRef idx="minor">
-            <a:schemeClr val="lt1"/>
-          </a:fontRef>
-        </p:style>
-        <p:txBody>
-          <a:bodyPr rtlCol="0" anchor="ctr"/>
-          <a:lstStyle/>
-          <a:p>
-            <a:pPr algn="ctr"/>
-          </a:p>
-        </p:txBody>
-      </p:sp>
-      <p:sp>
-        <p:nvSpPr>
           <p:cNvPr id="13" name="Oval 12"/>
           <p:cNvSpPr/>
           <p:nvPr/>
         </p:nvSpPr>
         <p:spPr>
           <a:xfrm>
-            <a:off x="8858250" y="12363450"/>
+            <a:off x="9144000" y="12363450"/>
             <a:ext cx="152400" cy="152400"/>
           </a:xfrm>
           <a:prstGeom prst="ellipse">
@@ -6176,50 +6055,6 @@
       <p:sp>
         <p:nvSpPr>
           <p:cNvPr id="14" name="Oval 13"/>
-          <p:cNvSpPr/>
-          <p:nvPr/>
-        </p:nvSpPr>
-        <p:spPr>
-          <a:xfrm>
-            <a:off x="9144000" y="12363450"/>
-            <a:ext cx="152400" cy="152400"/>
-          </a:xfrm>
-          <a:prstGeom prst="ellipse">
-            <a:avLst/>
-          </a:prstGeom>
-          <a:solidFill>
-            <a:srgbClr val="A7B097"/>
-          </a:solidFill>
-          <a:ln>
-            <a:noFill/>
-          </a:ln>
-          <a:effectLst/>
-        </p:spPr>
-        <p:style>
-          <a:lnRef idx="1">
-            <a:schemeClr val="accent1"/>
-          </a:lnRef>
-          <a:fillRef idx="3">
-            <a:schemeClr val="accent1"/>
-          </a:fillRef>
-          <a:effectRef idx="2">
-            <a:schemeClr val="accent1"/>
-          </a:effectRef>
-          <a:fontRef idx="minor">
-            <a:schemeClr val="lt1"/>
-          </a:fontRef>
-        </p:style>
-        <p:txBody>
-          <a:bodyPr rtlCol="0" anchor="ctr"/>
-          <a:lstStyle/>
-          <a:p>
-            <a:pPr algn="ctr"/>
-          </a:p>
-        </p:txBody>
-      </p:sp>
-      <p:sp>
-        <p:nvSpPr>
-          <p:cNvPr id="15" name="Oval 14"/>
           <p:cNvSpPr/>
           <p:nvPr/>
         </p:nvSpPr>
@@ -6331,16 +6166,180 @@
           </a:p>
         </p:txBody>
       </p:sp>
-      <p:sp>
-        <p:nvSpPr>
-          <p:cNvPr id="3" name="Oval 2"/>
-          <p:cNvSpPr/>
-          <p:nvPr/>
-        </p:nvSpPr>
+      <p:pic>
+        <p:nvPicPr>
+          <p:cNvPr id="3" name="Picture 2" descr=".circle-440.png"/>
+          <p:cNvPicPr>
+            <a:picLocks noChangeAspect="1"/>
+          </p:cNvPicPr>
+          <p:nvPr/>
+        </p:nvPicPr>
+        <p:blipFill>
+          <a:blip r:embed="rId3"/>
+          <a:stretch>
+            <a:fillRect/>
+          </a:stretch>
+        </p:blipFill>
         <p:spPr>
           <a:xfrm>
             <a:off x="3048000" y="1047750"/>
             <a:ext cx="4191000" cy="4191000"/>
+          </a:xfrm>
+          <a:prstGeom prst="rect">
+            <a:avLst/>
+          </a:prstGeom>
+        </p:spPr>
+      </p:pic>
+      <p:sp>
+        <p:nvSpPr>
+          <p:cNvPr id="4" name="TextBox 3"/>
+          <p:cNvSpPr txBox="1"/>
+          <p:nvPr/>
+        </p:nvSpPr>
+        <p:spPr>
+          <a:xfrm>
+            <a:off x="762000" y="5905500"/>
+            <a:ext cx="8763000" cy="762000"/>
+          </a:xfrm>
+          <a:prstGeom prst="rect">
+            <a:avLst/>
+          </a:prstGeom>
+          <a:noFill/>
+        </p:spPr>
+        <p:txBody>
+          <a:bodyPr wrap="square" lIns="0" rIns="0" tIns="0" bIns="0" anchor="t">
+            <a:spAutoFit/>
+          </a:bodyPr>
+          <a:lstStyle/>
+          <a:p>
+            <a:pPr algn="ctr"/>
+            <a:r>
+              <a:rPr sz="4800" b="1" i="0">
+                <a:solidFill>
+                  <a:srgbClr val="22371F"/>
+                </a:solidFill>
+                <a:latin typeface="Montserrat"/>
+              </a:rPr>
+              <a:t>Gerald Ramirez</a:t>
+            </a:r>
+          </a:p>
+        </p:txBody>
+      </p:sp>
+      <p:sp>
+        <p:nvSpPr>
+          <p:cNvPr id="5" name="TextBox 4"/>
+          <p:cNvSpPr txBox="1"/>
+          <p:nvPr/>
+        </p:nvSpPr>
+        <p:spPr>
+          <a:xfrm>
+            <a:off x="762000" y="6715125"/>
+            <a:ext cx="8763000" cy="571500"/>
+          </a:xfrm>
+          <a:prstGeom prst="rect">
+            <a:avLst/>
+          </a:prstGeom>
+          <a:noFill/>
+        </p:spPr>
+        <p:txBody>
+          <a:bodyPr wrap="square" lIns="0" rIns="0" tIns="0" bIns="0" anchor="t">
+            <a:spAutoFit/>
+          </a:bodyPr>
+          <a:lstStyle/>
+          <a:p>
+            <a:pPr algn="ctr"/>
+            <a:r>
+              <a:rPr sz="3300" b="0" i="0">
+                <a:solidFill>
+                  <a:srgbClr val="156826"/>
+                </a:solidFill>
+                <a:latin typeface="Source Sans 3"/>
+              </a:rPr>
+              <a:t>Compost extracts and teas</a:t>
+            </a:r>
+          </a:p>
+        </p:txBody>
+      </p:sp>
+      <p:sp>
+        <p:nvSpPr>
+          <p:cNvPr id="6" name="TextBox 5"/>
+          <p:cNvSpPr txBox="1"/>
+          <p:nvPr/>
+        </p:nvSpPr>
+        <p:spPr>
+          <a:xfrm>
+            <a:off x="762000" y="7620000"/>
+            <a:ext cx="8763000" cy="3619500"/>
+          </a:xfrm>
+          <a:prstGeom prst="rect">
+            <a:avLst/>
+          </a:prstGeom>
+          <a:noFill/>
+        </p:spPr>
+        <p:txBody>
+          <a:bodyPr wrap="square" lIns="0" rIns="0" tIns="0" bIns="0" anchor="t">
+            <a:spAutoFit/>
+          </a:bodyPr>
+          <a:lstStyle/>
+          <a:p>
+            <a:pPr algn="ctr"/>
+            <a:r>
+              <a:rPr sz="5700" b="0" i="0">
+                <a:solidFill>
+                  <a:srgbClr val="22371F"/>
+                </a:solidFill>
+                <a:latin typeface="Source Sans 3"/>
+              </a:rPr>
+              <a:t>[COPY: Allison] “[PLACEHOLDER tip]”</a:t>
+            </a:r>
+          </a:p>
+        </p:txBody>
+      </p:sp>
+      <p:sp>
+        <p:nvSpPr>
+          <p:cNvPr id="7" name="TextBox 6"/>
+          <p:cNvSpPr txBox="1"/>
+          <p:nvPr/>
+        </p:nvSpPr>
+        <p:spPr>
+          <a:xfrm>
+            <a:off x="571500" y="12192000"/>
+            <a:ext cx="9144000" cy="342900"/>
+          </a:xfrm>
+          <a:prstGeom prst="rect">
+            <a:avLst/>
+          </a:prstGeom>
+          <a:noFill/>
+        </p:spPr>
+        <p:txBody>
+          <a:bodyPr wrap="square" lIns="0" rIns="0" tIns="0" bIns="0" anchor="t">
+            <a:spAutoFit/>
+          </a:bodyPr>
+          <a:lstStyle/>
+          <a:p>
+            <a:pPr algn="l"/>
+            <a:r>
+              <a:rPr sz="3000" b="1" i="0">
+                <a:solidFill>
+                  <a:srgbClr val="6A665C"/>
+                </a:solidFill>
+                <a:latin typeface="Montserrat"/>
+              </a:rPr>
+              <a:t>@soilfoodwebschool</a:t>
+            </a:r>
+          </a:p>
+        </p:txBody>
+      </p:sp>
+      <p:sp>
+        <p:nvSpPr>
+          <p:cNvPr id="8" name="Oval 7"/>
+          <p:cNvSpPr/>
+          <p:nvPr/>
+        </p:nvSpPr>
+        <p:spPr>
+          <a:xfrm>
+            <a:off x="7715250" y="12363450"/>
+            <a:ext cx="152400" cy="152400"/>
           </a:xfrm>
           <a:prstGeom prst="ellipse">
             <a:avLst/>
@@ -6377,188 +6376,13 @@
       </p:sp>
       <p:sp>
         <p:nvSpPr>
-          <p:cNvPr id="4" name="TextBox 3"/>
-          <p:cNvSpPr txBox="1"/>
-          <p:nvPr/>
-        </p:nvSpPr>
-        <p:spPr>
-          <a:xfrm>
-            <a:off x="3429000" y="1047750"/>
-            <a:ext cx="3429000" cy="4191000"/>
-          </a:xfrm>
-          <a:prstGeom prst="rect">
-            <a:avLst/>
-          </a:prstGeom>
-          <a:noFill/>
-        </p:spPr>
-        <p:txBody>
-          <a:bodyPr wrap="square" lIns="0" rIns="0" tIns="0" bIns="0" anchor="ctr">
-            <a:spAutoFit/>
-          </a:bodyPr>
-          <a:lstStyle/>
-          <a:p>
-            <a:pPr algn="ctr"/>
-            <a:r>
-              <a:rPr sz="3000" b="1" i="0">
-                <a:solidFill>
-                  <a:srgbClr val="22371F"/>
-                </a:solidFill>
-                <a:latin typeface="Montserrat"/>
-              </a:rPr>
-              <a:t>[PHOTO: Gerald Ramirez]</a:t>
-            </a:r>
-          </a:p>
-        </p:txBody>
-      </p:sp>
-      <p:sp>
-        <p:nvSpPr>
-          <p:cNvPr id="5" name="TextBox 4"/>
-          <p:cNvSpPr txBox="1"/>
-          <p:nvPr/>
-        </p:nvSpPr>
-        <p:spPr>
-          <a:xfrm>
-            <a:off x="762000" y="5905500"/>
-            <a:ext cx="8763000" cy="762000"/>
-          </a:xfrm>
-          <a:prstGeom prst="rect">
-            <a:avLst/>
-          </a:prstGeom>
-          <a:noFill/>
-        </p:spPr>
-        <p:txBody>
-          <a:bodyPr wrap="square" lIns="0" rIns="0" tIns="0" bIns="0" anchor="t">
-            <a:spAutoFit/>
-          </a:bodyPr>
-          <a:lstStyle/>
-          <a:p>
-            <a:pPr algn="ctr"/>
-            <a:r>
-              <a:rPr sz="4800" b="1" i="0">
-                <a:solidFill>
-                  <a:srgbClr val="22371F"/>
-                </a:solidFill>
-                <a:latin typeface="Montserrat"/>
-              </a:rPr>
-              <a:t>Gerald Ramirez</a:t>
-            </a:r>
-          </a:p>
-        </p:txBody>
-      </p:sp>
-      <p:sp>
-        <p:nvSpPr>
-          <p:cNvPr id="6" name="TextBox 5"/>
-          <p:cNvSpPr txBox="1"/>
-          <p:nvPr/>
-        </p:nvSpPr>
-        <p:spPr>
-          <a:xfrm>
-            <a:off x="762000" y="6715125"/>
-            <a:ext cx="8763000" cy="571500"/>
-          </a:xfrm>
-          <a:prstGeom prst="rect">
-            <a:avLst/>
-          </a:prstGeom>
-          <a:noFill/>
-        </p:spPr>
-        <p:txBody>
-          <a:bodyPr wrap="square" lIns="0" rIns="0" tIns="0" bIns="0" anchor="t">
-            <a:spAutoFit/>
-          </a:bodyPr>
-          <a:lstStyle/>
-          <a:p>
-            <a:pPr algn="ctr"/>
-            <a:r>
-              <a:rPr sz="3300" b="0" i="0">
-                <a:solidFill>
-                  <a:srgbClr val="156826"/>
-                </a:solidFill>
-                <a:latin typeface="Source Sans 3"/>
-              </a:rPr>
-              <a:t>Compost extracts and teas</a:t>
-            </a:r>
-          </a:p>
-        </p:txBody>
-      </p:sp>
-      <p:sp>
-        <p:nvSpPr>
-          <p:cNvPr id="7" name="TextBox 6"/>
-          <p:cNvSpPr txBox="1"/>
-          <p:nvPr/>
-        </p:nvSpPr>
-        <p:spPr>
-          <a:xfrm>
-            <a:off x="762000" y="7620000"/>
-            <a:ext cx="8763000" cy="3619500"/>
-          </a:xfrm>
-          <a:prstGeom prst="rect">
-            <a:avLst/>
-          </a:prstGeom>
-          <a:noFill/>
-        </p:spPr>
-        <p:txBody>
-          <a:bodyPr wrap="square" lIns="0" rIns="0" tIns="0" bIns="0" anchor="t">
-            <a:spAutoFit/>
-          </a:bodyPr>
-          <a:lstStyle/>
-          <a:p>
-            <a:pPr algn="ctr"/>
-            <a:r>
-              <a:rPr sz="5700" b="0" i="0">
-                <a:solidFill>
-                  <a:srgbClr val="22371F"/>
-                </a:solidFill>
-                <a:latin typeface="Source Sans 3"/>
-              </a:rPr>
-              <a:t>[COPY: Allison] “[PLACEHOLDER tip]”</a:t>
-            </a:r>
-          </a:p>
-        </p:txBody>
-      </p:sp>
-      <p:sp>
-        <p:nvSpPr>
-          <p:cNvPr id="8" name="TextBox 7"/>
-          <p:cNvSpPr txBox="1"/>
-          <p:nvPr/>
-        </p:nvSpPr>
-        <p:spPr>
-          <a:xfrm>
-            <a:off x="571500" y="12192000"/>
-            <a:ext cx="9144000" cy="342900"/>
-          </a:xfrm>
-          <a:prstGeom prst="rect">
-            <a:avLst/>
-          </a:prstGeom>
-          <a:noFill/>
-        </p:spPr>
-        <p:txBody>
-          <a:bodyPr wrap="square" lIns="0" rIns="0" tIns="0" bIns="0" anchor="t">
-            <a:spAutoFit/>
-          </a:bodyPr>
-          <a:lstStyle/>
-          <a:p>
-            <a:pPr algn="l"/>
-            <a:r>
-              <a:rPr sz="3000" b="1" i="0">
-                <a:solidFill>
-                  <a:srgbClr val="6A665C"/>
-                </a:solidFill>
-                <a:latin typeface="Montserrat"/>
-              </a:rPr>
-              <a:t>@soilfoodwebschool</a:t>
-            </a:r>
-          </a:p>
-        </p:txBody>
-      </p:sp>
-      <p:sp>
-        <p:nvSpPr>
           <p:cNvPr id="9" name="Oval 8"/>
           <p:cNvSpPr/>
           <p:nvPr/>
         </p:nvSpPr>
         <p:spPr>
           <a:xfrm>
-            <a:off x="7715250" y="12363450"/>
+            <a:off x="8001000" y="12363450"/>
             <a:ext cx="152400" cy="152400"/>
           </a:xfrm>
           <a:prstGeom prst="ellipse">
@@ -6602,7 +6426,7 @@
         </p:nvSpPr>
         <p:spPr>
           <a:xfrm>
-            <a:off x="8001000" y="12363450"/>
+            <a:off x="8286750" y="12363450"/>
             <a:ext cx="152400" cy="152400"/>
           </a:xfrm>
           <a:prstGeom prst="ellipse">
@@ -6646,7 +6470,7 @@
         </p:nvSpPr>
         <p:spPr>
           <a:xfrm>
-            <a:off x="8286750" y="12363450"/>
+            <a:off x="8572500" y="12363450"/>
             <a:ext cx="152400" cy="152400"/>
           </a:xfrm>
           <a:prstGeom prst="ellipse">
@@ -6690,7 +6514,51 @@
         </p:nvSpPr>
         <p:spPr>
           <a:xfrm>
-            <a:off x="8572500" y="12363450"/>
+            <a:off x="8858250" y="12363450"/>
+            <a:ext cx="152400" cy="152400"/>
+          </a:xfrm>
+          <a:prstGeom prst="ellipse">
+            <a:avLst/>
+          </a:prstGeom>
+          <a:solidFill>
+            <a:srgbClr val="156826"/>
+          </a:solidFill>
+          <a:ln>
+            <a:noFill/>
+          </a:ln>
+          <a:effectLst/>
+        </p:spPr>
+        <p:style>
+          <a:lnRef idx="1">
+            <a:schemeClr val="accent1"/>
+          </a:lnRef>
+          <a:fillRef idx="3">
+            <a:schemeClr val="accent1"/>
+          </a:fillRef>
+          <a:effectRef idx="2">
+            <a:schemeClr val="accent1"/>
+          </a:effectRef>
+          <a:fontRef idx="minor">
+            <a:schemeClr val="lt1"/>
+          </a:fontRef>
+        </p:style>
+        <p:txBody>
+          <a:bodyPr rtlCol="0" anchor="ctr"/>
+          <a:lstStyle/>
+          <a:p>
+            <a:pPr algn="ctr"/>
+          </a:p>
+        </p:txBody>
+      </p:sp>
+      <p:sp>
+        <p:nvSpPr>
+          <p:cNvPr id="13" name="Oval 12"/>
+          <p:cNvSpPr/>
+          <p:nvPr/>
+        </p:nvSpPr>
+        <p:spPr>
+          <a:xfrm>
+            <a:off x="9144000" y="12363450"/>
             <a:ext cx="152400" cy="152400"/>
           </a:xfrm>
           <a:prstGeom prst="ellipse">
@@ -6728,95 +6596,7 @@
       </p:sp>
       <p:sp>
         <p:nvSpPr>
-          <p:cNvPr id="13" name="Oval 12"/>
-          <p:cNvSpPr/>
-          <p:nvPr/>
-        </p:nvSpPr>
-        <p:spPr>
-          <a:xfrm>
-            <a:off x="8858250" y="12363450"/>
-            <a:ext cx="152400" cy="152400"/>
-          </a:xfrm>
-          <a:prstGeom prst="ellipse">
-            <a:avLst/>
-          </a:prstGeom>
-          <a:solidFill>
-            <a:srgbClr val="156826"/>
-          </a:solidFill>
-          <a:ln>
-            <a:noFill/>
-          </a:ln>
-          <a:effectLst/>
-        </p:spPr>
-        <p:style>
-          <a:lnRef idx="1">
-            <a:schemeClr val="accent1"/>
-          </a:lnRef>
-          <a:fillRef idx="3">
-            <a:schemeClr val="accent1"/>
-          </a:fillRef>
-          <a:effectRef idx="2">
-            <a:schemeClr val="accent1"/>
-          </a:effectRef>
-          <a:fontRef idx="minor">
-            <a:schemeClr val="lt1"/>
-          </a:fontRef>
-        </p:style>
-        <p:txBody>
-          <a:bodyPr rtlCol="0" anchor="ctr"/>
-          <a:lstStyle/>
-          <a:p>
-            <a:pPr algn="ctr"/>
-          </a:p>
-        </p:txBody>
-      </p:sp>
-      <p:sp>
-        <p:nvSpPr>
           <p:cNvPr id="14" name="Oval 13"/>
-          <p:cNvSpPr/>
-          <p:nvPr/>
-        </p:nvSpPr>
-        <p:spPr>
-          <a:xfrm>
-            <a:off x="9144000" y="12363450"/>
-            <a:ext cx="152400" cy="152400"/>
-          </a:xfrm>
-          <a:prstGeom prst="ellipse">
-            <a:avLst/>
-          </a:prstGeom>
-          <a:solidFill>
-            <a:srgbClr val="A7B097"/>
-          </a:solidFill>
-          <a:ln>
-            <a:noFill/>
-          </a:ln>
-          <a:effectLst/>
-        </p:spPr>
-        <p:style>
-          <a:lnRef idx="1">
-            <a:schemeClr val="accent1"/>
-          </a:lnRef>
-          <a:fillRef idx="3">
-            <a:schemeClr val="accent1"/>
-          </a:fillRef>
-          <a:effectRef idx="2">
-            <a:schemeClr val="accent1"/>
-          </a:effectRef>
-          <a:fontRef idx="minor">
-            <a:schemeClr val="lt1"/>
-          </a:fontRef>
-        </p:style>
-        <p:txBody>
-          <a:bodyPr rtlCol="0" anchor="ctr"/>
-          <a:lstStyle/>
-          <a:p>
-            <a:pPr algn="ctr"/>
-          </a:p>
-        </p:txBody>
-      </p:sp>
-      <p:sp>
-        <p:nvSpPr>
-          <p:cNvPr id="15" name="Oval 14"/>
           <p:cNvSpPr/>
           <p:nvPr/>
         </p:nvSpPr>

</xml_diff>

<commit_message>
Spell Gerald Ramírez with the accent everywhere, as on his instructor post
</commit_message>
<xml_diff>
--- a/templates/carousels/posts/05-10-2026-mon-teachers-day-five-mentors.pptx
+++ b/templates/carousels/posts/05-10-2026-mon-teachers-day-five-mentors.pptx
@@ -813,7 +813,7 @@
           </a:p>
           <a:p>
             <a:r>
-              <a:t>Slide 5 of 7. Gerald Ramirez, Compost extracts and teas. Portrait: round headshot from the website, with consent. Tip: from Allison's question 'What is the one thing you wish every new student knew?' One or two sentences, in the mentor's words.</a:t>
+              <a:t>Slide 5 of 7. Gerald Ramírez, Compost extracts and teas. Portrait: round headshot from the website, with consent. Tip: from Allison's question 'What is the one thing you wish every new student knew?' One or two sentences, in the mentor's words.</a:t>
             </a:r>
           </a:p>
         </p:txBody>
@@ -3979,7 +3979,7 @@
       <p:grpSpPr/>
       <p:pic>
         <p:nvPicPr>
-          <p:cNvPr id="2" name="Picture 1" descr="1601954559531201609.jpg"/>
+          <p:cNvPr id="2" name="Picture 1" descr="3848633987896859391.jpg"/>
           <p:cNvPicPr>
             <a:picLocks noChangeAspect="1"/>
           </p:cNvPicPr>
@@ -6220,7 +6220,7 @@
                 </a:solidFill>
                 <a:latin typeface="Montserrat"/>
               </a:rPr>
-              <a:t>Gerald Ramirez</a:t>
+              <a:t>Gerald Ramírez</a:t>
             </a:r>
           </a:p>
         </p:txBody>

</xml_diff>